<commit_message>
Clarify slide 2: show 1C vs Space Planner instead of source/agent chips
Co-authored-by: Alena931 <Alena931@users.noreply.github.com>
</commit_message>
<xml_diff>
--- a/Tovaroved_karta_konkurentov.pptx
+++ b/Tovaroved_karta_konkurentov.pptx
@@ -4658,16 +4658,16 @@
         </p:nvSpPr>
         <p:spPr>
           <a:xfrm>
-            <a:off x="777240" y="2788920"/>
-            <a:ext cx="1325880" cy="347472"/>
+            <a:off x="777240" y="2761488"/>
+            <a:ext cx="2240280" cy="713232"/>
           </a:xfrm>
           <a:prstGeom prst="roundRect">
             <a:avLst>
-              <a:gd name="adj" fmla="val 20000"/>
+              <a:gd name="adj" fmla="val 10000"/>
             </a:avLst>
           </a:prstGeom>
           <a:solidFill>
-            <a:srgbClr val="5E6F64"/>
+            <a:srgbClr val="E8E4DC"/>
           </a:solidFill>
           <a:ln>
             <a:noFill/>
@@ -4693,13 +4693,13 @@
           <a:p>
             <a:pPr algn="ctr"/>
             <a:r>
-              <a:rPr sz="1100" b="1" i="0">
-                <a:solidFill>
-                  <a:srgbClr val="FFFFFF"/>
-                </a:solidFill>
-                <a:latin typeface="Calibri"/>
-              </a:rPr>
-              <a:t>источник</a:t>
+              <a:rPr sz="1300" b="1" i="0">
+                <a:solidFill>
+                  <a:srgbClr val="3A5466"/>
+                </a:solidFill>
+                <a:latin typeface="Calibri"/>
+              </a:rPr>
+              <a:t>пишут в 1С</a:t>
             </a:r>
           </a:p>
         </p:txBody>
@@ -4712,16 +4712,16 @@
         </p:nvSpPr>
         <p:spPr>
           <a:xfrm>
-            <a:off x="2286000" y="2788920"/>
-            <a:ext cx="1325880" cy="347472"/>
+            <a:off x="3200400" y="2761488"/>
+            <a:ext cx="2331720" cy="713232"/>
           </a:xfrm>
           <a:prstGeom prst="roundRect">
             <a:avLst>
-              <a:gd name="adj" fmla="val 20000"/>
+              <a:gd name="adj" fmla="val 10000"/>
             </a:avLst>
           </a:prstGeom>
           <a:solidFill>
-            <a:srgbClr val="5E6F64"/>
+            <a:srgbClr val="EBE4DF"/>
           </a:solidFill>
           <a:ln>
             <a:noFill/>
@@ -4747,114 +4747,26 @@
           <a:p>
             <a:pPr algn="ctr"/>
             <a:r>
-              <a:rPr sz="1100" b="1" i="0">
-                <a:solidFill>
-                  <a:srgbClr val="FFFFFF"/>
-                </a:solidFill>
-                <a:latin typeface="Calibri"/>
-              </a:rPr>
-              <a:t>агент</a:t>
-            </a:r>
-          </a:p>
-        </p:txBody>
-      </p:sp>
-      <p:sp>
-        <p:nvSpPr>
-          <p:cNvPr id="13" name="Rounded Rectangle 12"/>
-          <p:cNvSpPr/>
-          <p:nvPr/>
-        </p:nvSpPr>
-        <p:spPr>
-          <a:xfrm>
-            <a:off x="3794760" y="2788920"/>
-            <a:ext cx="1325880" cy="347472"/>
-          </a:xfrm>
-          <a:prstGeom prst="roundRect">
-            <a:avLst>
-              <a:gd name="adj" fmla="val 20000"/>
-            </a:avLst>
-          </a:prstGeom>
-          <a:solidFill>
-            <a:srgbClr val="3A5466"/>
-          </a:solidFill>
-          <a:ln>
-            <a:noFill/>
-          </a:ln>
-        </p:spPr>
-        <p:style>
-          <a:lnRef idx="1">
-            <a:schemeClr val="accent1"/>
-          </a:lnRef>
-          <a:fillRef idx="3">
-            <a:schemeClr val="accent1"/>
-          </a:fillRef>
-          <a:effectRef idx="2">
-            <a:schemeClr val="accent1"/>
-          </a:effectRef>
-          <a:fontRef idx="minor">
-            <a:schemeClr val="lt1"/>
-          </a:fontRef>
-        </p:style>
-        <p:txBody>
-          <a:bodyPr rtlCol="0" anchor="ctr"/>
-          <a:lstStyle/>
-          <a:p>
-            <a:pPr algn="ctr"/>
-            <a:r>
-              <a:rPr sz="1100" b="1" i="0">
-                <a:solidFill>
-                  <a:srgbClr val="FFFFFF"/>
-                </a:solidFill>
-                <a:latin typeface="Calibri"/>
-              </a:rPr>
-              <a:t>1С</a:t>
-            </a:r>
-          </a:p>
-        </p:txBody>
-      </p:sp>
-      <p:sp>
-        <p:nvSpPr>
-          <p:cNvPr id="14" name="TextBox 13"/>
+              <a:rPr sz="1300" b="1" i="0">
+                <a:solidFill>
+                  <a:srgbClr val="8B5A4A"/>
+                </a:solidFill>
+                <a:latin typeface="Calibri"/>
+              </a:rPr>
+              <a:t>в Space Planner — нет</a:t>
+            </a:r>
+          </a:p>
+        </p:txBody>
+      </p:sp>
+      <p:sp>
+        <p:nvSpPr>
+          <p:cNvPr id="13" name="TextBox 12"/>
           <p:cNvSpPr txBox="1"/>
           <p:nvPr/>
         </p:nvSpPr>
         <p:spPr>
           <a:xfrm>
-            <a:off x="777240" y="3246120"/>
-            <a:ext cx="4754880" cy="274320"/>
-          </a:xfrm>
-          <a:prstGeom prst="rect">
-            <a:avLst/>
-          </a:prstGeom>
-          <a:noFill/>
-        </p:spPr>
-        <p:txBody>
-          <a:bodyPr wrap="none">
-            <a:spAutoFit/>
-          </a:bodyPr>
-          <a:lstStyle/>
-          <a:p>
-            <a:r>
-              <a:rPr sz="1200" b="1" i="0">
-                <a:solidFill>
-                  <a:srgbClr val="8B5A4A"/>
-                </a:solidFill>
-                <a:latin typeface="Calibri"/>
-              </a:rPr>
-              <a:t>выхода в Space Planner нет</a:t>
-            </a:r>
-          </a:p>
-        </p:txBody>
-      </p:sp>
-      <p:sp>
-        <p:nvSpPr>
-          <p:cNvPr id="15" name="TextBox 14"/>
-          <p:cNvSpPr txBox="1"/>
-          <p:nvPr/>
-        </p:nvSpPr>
-        <p:spPr>
-          <a:xfrm>
-            <a:off x="777240" y="3611880"/>
+            <a:off x="777240" y="3630168"/>
             <a:ext cx="4754880" cy="1371600"/>
           </a:xfrm>
           <a:prstGeom prst="rect">
@@ -4903,7 +4815,7 @@
       </p:sp>
       <p:sp>
         <p:nvSpPr>
-          <p:cNvPr id="16" name="TextBox 15"/>
+          <p:cNvPr id="14" name="TextBox 13"/>
           <p:cNvSpPr txBox="1"/>
           <p:nvPr/>
         </p:nvSpPr>
@@ -4939,7 +4851,7 @@
       </p:sp>
       <p:sp>
         <p:nvSpPr>
-          <p:cNvPr id="17" name="Rounded Rectangle 16"/>
+          <p:cNvPr id="15" name="Rounded Rectangle 14"/>
           <p:cNvSpPr/>
           <p:nvPr/>
         </p:nvSpPr>
@@ -4986,7 +4898,7 @@
       </p:sp>
       <p:sp>
         <p:nvSpPr>
-          <p:cNvPr id="18" name="Rectangle 17"/>
+          <p:cNvPr id="16" name="Rectangle 15"/>
           <p:cNvSpPr/>
           <p:nvPr/>
         </p:nvSpPr>
@@ -5029,7 +4941,7 @@
       </p:sp>
       <p:sp>
         <p:nvSpPr>
-          <p:cNvPr id="19" name="TextBox 18"/>
+          <p:cNvPr id="17" name="TextBox 16"/>
           <p:cNvSpPr txBox="1"/>
           <p:nvPr/>
         </p:nvSpPr>
@@ -5063,7 +4975,7 @@
       </p:sp>
       <p:sp>
         <p:nvSpPr>
-          <p:cNvPr id="20" name="TextBox 19"/>
+          <p:cNvPr id="18" name="TextBox 17"/>
           <p:cNvSpPr txBox="1"/>
           <p:nvPr/>
         </p:nvSpPr>
@@ -5097,7 +5009,7 @@
       </p:sp>
       <p:sp>
         <p:nvSpPr>
-          <p:cNvPr id="21" name="TextBox 20"/>
+          <p:cNvPr id="19" name="TextBox 18"/>
           <p:cNvSpPr txBox="1"/>
           <p:nvPr/>
         </p:nvSpPr>
@@ -5131,19 +5043,250 @@
       </p:sp>
       <p:sp>
         <p:nvSpPr>
-          <p:cNvPr id="22" name="Rounded Rectangle 21"/>
+          <p:cNvPr id="20" name="Rounded Rectangle 19"/>
           <p:cNvSpPr/>
           <p:nvPr/>
         </p:nvSpPr>
         <p:spPr>
           <a:xfrm>
-            <a:off x="6583680" y="2788920"/>
-            <a:ext cx="1325880" cy="347472"/>
+            <a:off x="6583680" y="2761488"/>
+            <a:ext cx="2240280" cy="713232"/>
           </a:xfrm>
           <a:prstGeom prst="roundRect">
             <a:avLst>
-              <a:gd name="adj" fmla="val 20000"/>
+              <a:gd name="adj" fmla="val 10000"/>
             </a:avLst>
+          </a:prstGeom>
+          <a:solidFill>
+            <a:srgbClr val="E8E4DC"/>
+          </a:solidFill>
+          <a:ln>
+            <a:noFill/>
+          </a:ln>
+        </p:spPr>
+        <p:style>
+          <a:lnRef idx="1">
+            <a:schemeClr val="accent1"/>
+          </a:lnRef>
+          <a:fillRef idx="3">
+            <a:schemeClr val="accent1"/>
+          </a:fillRef>
+          <a:effectRef idx="2">
+            <a:schemeClr val="accent1"/>
+          </a:effectRef>
+          <a:fontRef idx="minor">
+            <a:schemeClr val="lt1"/>
+          </a:fontRef>
+        </p:style>
+        <p:txBody>
+          <a:bodyPr rtlCol="0" anchor="ctr"/>
+          <a:lstStyle/>
+          <a:p>
+            <a:pPr algn="ctr"/>
+            <a:r>
+              <a:rPr sz="1300" b="1" i="0">
+                <a:solidFill>
+                  <a:srgbClr val="3A5466"/>
+                </a:solidFill>
+                <a:latin typeface="Calibri"/>
+              </a:rPr>
+              <a:t>пишут в 1С</a:t>
+            </a:r>
+          </a:p>
+        </p:txBody>
+      </p:sp>
+      <p:sp>
+        <p:nvSpPr>
+          <p:cNvPr id="21" name="Rounded Rectangle 20"/>
+          <p:cNvSpPr/>
+          <p:nvPr/>
+        </p:nvSpPr>
+        <p:spPr>
+          <a:xfrm>
+            <a:off x="9006840" y="2761488"/>
+            <a:ext cx="2331720" cy="713232"/>
+          </a:xfrm>
+          <a:prstGeom prst="roundRect">
+            <a:avLst>
+              <a:gd name="adj" fmla="val 10000"/>
+            </a:avLst>
+          </a:prstGeom>
+          <a:solidFill>
+            <a:srgbClr val="EBE4DF"/>
+          </a:solidFill>
+          <a:ln>
+            <a:noFill/>
+          </a:ln>
+        </p:spPr>
+        <p:style>
+          <a:lnRef idx="1">
+            <a:schemeClr val="accent1"/>
+          </a:lnRef>
+          <a:fillRef idx="3">
+            <a:schemeClr val="accent1"/>
+          </a:fillRef>
+          <a:effectRef idx="2">
+            <a:schemeClr val="accent1"/>
+          </a:effectRef>
+          <a:fontRef idx="minor">
+            <a:schemeClr val="lt1"/>
+          </a:fontRef>
+        </p:style>
+        <p:txBody>
+          <a:bodyPr rtlCol="0" anchor="ctr"/>
+          <a:lstStyle/>
+          <a:p>
+            <a:pPr algn="ctr"/>
+            <a:r>
+              <a:rPr sz="1300" b="1" i="0">
+                <a:solidFill>
+                  <a:srgbClr val="8B5A4A"/>
+                </a:solidFill>
+                <a:latin typeface="Calibri"/>
+              </a:rPr>
+              <a:t>в Space Planner — нет</a:t>
+            </a:r>
+          </a:p>
+        </p:txBody>
+      </p:sp>
+      <p:sp>
+        <p:nvSpPr>
+          <p:cNvPr id="22" name="TextBox 21"/>
+          <p:cNvSpPr txBox="1"/>
+          <p:nvPr/>
+        </p:nvSpPr>
+        <p:spPr>
+          <a:xfrm>
+            <a:off x="6583680" y="3630168"/>
+            <a:ext cx="4754880" cy="1371600"/>
+          </a:xfrm>
+          <a:prstGeom prst="rect">
+            <a:avLst/>
+          </a:prstGeom>
+          <a:noFill/>
+        </p:spPr>
+        <p:txBody>
+          <a:bodyPr wrap="square">
+            <a:spAutoFit/>
+          </a:bodyPr>
+          <a:lstStyle/>
+          <a:p>
+            <a:pPr>
+              <a:spcAft>
+                <a:spcPts val="400"/>
+              </a:spcAft>
+            </a:pPr>
+            <a:r>
+              <a:rPr sz="1300" b="0" i="0">
+                <a:solidFill>
+                  <a:srgbClr val="2B3642"/>
+                </a:solidFill>
+                <a:latin typeface="Calibri"/>
+              </a:rPr>
+              <a:t>▸  результат в 1С, не в SP</a:t>
+            </a:r>
+          </a:p>
+          <a:p>
+            <a:pPr>
+              <a:spcAft>
+                <a:spcPts val="400"/>
+              </a:spcAft>
+            </a:pPr>
+            <a:r>
+              <a:rPr sz="1300" b="0" i="0">
+                <a:solidFill>
+                  <a:srgbClr val="2B3642"/>
+                </a:solidFill>
+                <a:latin typeface="Calibri"/>
+              </a:rPr>
+              <a:t>▸  логистические меры ≠ WxHxD facing</a:t>
+            </a:r>
+          </a:p>
+        </p:txBody>
+      </p:sp>
+      <p:sp>
+        <p:nvSpPr>
+          <p:cNvPr id="23" name="TextBox 22"/>
+          <p:cNvSpPr txBox="1"/>
+          <p:nvPr/>
+        </p:nvSpPr>
+        <p:spPr>
+          <a:xfrm>
+            <a:off x="6583680" y="5029200"/>
+            <a:ext cx="4754880" cy="365760"/>
+          </a:xfrm>
+          <a:prstGeom prst="rect">
+            <a:avLst/>
+          </a:prstGeom>
+          <a:noFill/>
+        </p:spPr>
+        <p:txBody>
+          <a:bodyPr wrap="square">
+            <a:spAutoFit/>
+          </a:bodyPr>
+          <a:lstStyle/>
+          <a:p>
+            <a:pPr algn="l"/>
+            <a:r>
+              <a:rPr sz="1000" b="0" i="0" u="sng">
+                <a:solidFill>
+                  <a:srgbClr val="4A6B7C"/>
+                </a:solidFill>
+                <a:latin typeface="Calibri"/>
+                <a:hlinkClick r:id="rId3"/>
+              </a:rPr>
+              <a:t>https://infostart.ru/marketplace/2667216/</a:t>
+            </a:r>
+          </a:p>
+        </p:txBody>
+      </p:sp>
+      <p:sp>
+        <p:nvSpPr>
+          <p:cNvPr id="24" name="TextBox 23"/>
+          <p:cNvSpPr txBox="1"/>
+          <p:nvPr/>
+        </p:nvSpPr>
+        <p:spPr>
+          <a:xfrm>
+            <a:off x="6583680" y="4754880"/>
+            <a:ext cx="4754880" cy="256032"/>
+          </a:xfrm>
+          <a:prstGeom prst="rect">
+            <a:avLst/>
+          </a:prstGeom>
+          <a:noFill/>
+        </p:spPr>
+        <p:txBody>
+          <a:bodyPr wrap="none">
+            <a:spAutoFit/>
+          </a:bodyPr>
+          <a:lstStyle/>
+          <a:p>
+            <a:r>
+              <a:rPr sz="1200" b="1" i="0">
+                <a:solidFill>
+                  <a:srgbClr val="3A5466"/>
+                </a:solidFill>
+                <a:latin typeface="Calibri"/>
+              </a:rPr>
+              <a:t>48 800 ₽ / мес + пакеты запросов</a:t>
+            </a:r>
+          </a:p>
+        </p:txBody>
+      </p:sp>
+      <p:sp>
+        <p:nvSpPr>
+          <p:cNvPr id="25" name="Rectangle 24"/>
+          <p:cNvSpPr/>
+          <p:nvPr/>
+        </p:nvSpPr>
+        <p:spPr>
+          <a:xfrm>
+            <a:off x="0" y="6656832"/>
+            <a:ext cx="12191695" cy="201168"/>
+          </a:xfrm>
+          <a:prstGeom prst="rect">
+            <a:avLst/>
           </a:prstGeom>
           <a:solidFill>
             <a:srgbClr val="3A5466"/>
@@ -5171,136 +5314,19 @@
           <a:lstStyle/>
           <a:p>
             <a:pPr algn="ctr"/>
-            <a:r>
-              <a:rPr sz="1100" b="1" i="0">
-                <a:solidFill>
-                  <a:srgbClr val="FFFFFF"/>
-                </a:solidFill>
-                <a:latin typeface="Calibri"/>
-              </a:rPr>
-              <a:t>источник</a:t>
-            </a:r>
-          </a:p>
-        </p:txBody>
-      </p:sp>
-      <p:sp>
-        <p:nvSpPr>
-          <p:cNvPr id="23" name="Rounded Rectangle 22"/>
-          <p:cNvSpPr/>
-          <p:nvPr/>
-        </p:nvSpPr>
-        <p:spPr>
-          <a:xfrm>
-            <a:off x="8092440" y="2788920"/>
-            <a:ext cx="1325880" cy="347472"/>
-          </a:xfrm>
-          <a:prstGeom prst="roundRect">
-            <a:avLst>
-              <a:gd name="adj" fmla="val 20000"/>
-            </a:avLst>
-          </a:prstGeom>
-          <a:solidFill>
-            <a:srgbClr val="5E6F64"/>
-          </a:solidFill>
-          <a:ln>
-            <a:noFill/>
-          </a:ln>
-        </p:spPr>
-        <p:style>
-          <a:lnRef idx="1">
-            <a:schemeClr val="accent1"/>
-          </a:lnRef>
-          <a:fillRef idx="3">
-            <a:schemeClr val="accent1"/>
-          </a:fillRef>
-          <a:effectRef idx="2">
-            <a:schemeClr val="accent1"/>
-          </a:effectRef>
-          <a:fontRef idx="minor">
-            <a:schemeClr val="lt1"/>
-          </a:fontRef>
-        </p:style>
-        <p:txBody>
-          <a:bodyPr rtlCol="0" anchor="ctr"/>
-          <a:lstStyle/>
-          <a:p>
-            <a:pPr algn="ctr"/>
-            <a:r>
-              <a:rPr sz="1100" b="1" i="0">
-                <a:solidFill>
-                  <a:srgbClr val="FFFFFF"/>
-                </a:solidFill>
-                <a:latin typeface="Calibri"/>
-              </a:rPr>
-              <a:t>агент</a:t>
-            </a:r>
-          </a:p>
-        </p:txBody>
-      </p:sp>
-      <p:sp>
-        <p:nvSpPr>
-          <p:cNvPr id="24" name="Rounded Rectangle 23"/>
-          <p:cNvSpPr/>
-          <p:nvPr/>
-        </p:nvSpPr>
-        <p:spPr>
-          <a:xfrm>
-            <a:off x="9601200" y="2788920"/>
-            <a:ext cx="1325880" cy="347472"/>
-          </a:xfrm>
-          <a:prstGeom prst="roundRect">
-            <a:avLst>
-              <a:gd name="adj" fmla="val 20000"/>
-            </a:avLst>
-          </a:prstGeom>
-          <a:solidFill>
-            <a:srgbClr val="3A5466"/>
-          </a:solidFill>
-          <a:ln>
-            <a:noFill/>
-          </a:ln>
-        </p:spPr>
-        <p:style>
-          <a:lnRef idx="1">
-            <a:schemeClr val="accent1"/>
-          </a:lnRef>
-          <a:fillRef idx="3">
-            <a:schemeClr val="accent1"/>
-          </a:fillRef>
-          <a:effectRef idx="2">
-            <a:schemeClr val="accent1"/>
-          </a:effectRef>
-          <a:fontRef idx="minor">
-            <a:schemeClr val="lt1"/>
-          </a:fontRef>
-        </p:style>
-        <p:txBody>
-          <a:bodyPr rtlCol="0" anchor="ctr"/>
-          <a:lstStyle/>
-          <a:p>
-            <a:pPr algn="ctr"/>
-            <a:r>
-              <a:rPr sz="1100" b="1" i="0">
-                <a:solidFill>
-                  <a:srgbClr val="FFFFFF"/>
-                </a:solidFill>
-                <a:latin typeface="Calibri"/>
-              </a:rPr>
-              <a:t>1С</a:t>
-            </a:r>
-          </a:p>
-        </p:txBody>
-      </p:sp>
-      <p:sp>
-        <p:nvSpPr>
-          <p:cNvPr id="25" name="TextBox 24"/>
+          </a:p>
+        </p:txBody>
+      </p:sp>
+      <p:sp>
+        <p:nvSpPr>
+          <p:cNvPr id="26" name="TextBox 25"/>
           <p:cNvSpPr txBox="1"/>
           <p:nvPr/>
         </p:nvSpPr>
         <p:spPr>
           <a:xfrm>
-            <a:off x="6583680" y="3246120"/>
-            <a:ext cx="4754880" cy="274320"/>
+            <a:off x="457200" y="6656832"/>
+            <a:ext cx="9144000" cy="201168"/>
           </a:xfrm>
           <a:prstGeom prst="rect">
             <a:avLst/>
@@ -5314,68 +5340,13 @@
           <a:lstStyle/>
           <a:p>
             <a:r>
-              <a:rPr sz="1200" b="1" i="0">
-                <a:solidFill>
-                  <a:srgbClr val="8B5A4A"/>
-                </a:solidFill>
-                <a:latin typeface="Calibri"/>
-              </a:rPr>
-              <a:t>выхода в Space Planner нет</a:t>
-            </a:r>
-          </a:p>
-        </p:txBody>
-      </p:sp>
-      <p:sp>
-        <p:nvSpPr>
-          <p:cNvPr id="26" name="TextBox 25"/>
-          <p:cNvSpPr txBox="1"/>
-          <p:nvPr/>
-        </p:nvSpPr>
-        <p:spPr>
-          <a:xfrm>
-            <a:off x="6583680" y="3611880"/>
-            <a:ext cx="4754880" cy="1371600"/>
-          </a:xfrm>
-          <a:prstGeom prst="rect">
-            <a:avLst/>
-          </a:prstGeom>
-          <a:noFill/>
-        </p:spPr>
-        <p:txBody>
-          <a:bodyPr wrap="square">
-            <a:spAutoFit/>
-          </a:bodyPr>
-          <a:lstStyle/>
-          <a:p>
-            <a:pPr>
-              <a:spcAft>
-                <a:spcPts val="400"/>
-              </a:spcAft>
-            </a:pPr>
-            <a:r>
-              <a:rPr sz="1300" b="0" i="0">
-                <a:solidFill>
-                  <a:srgbClr val="2B3642"/>
-                </a:solidFill>
-                <a:latin typeface="Calibri"/>
-              </a:rPr>
-              <a:t>▸  результат в 1С, не в SP</a:t>
-            </a:r>
-          </a:p>
-          <a:p>
-            <a:pPr>
-              <a:spcAft>
-                <a:spcPts val="400"/>
-              </a:spcAft>
-            </a:pPr>
-            <a:r>
-              <a:rPr sz="1300" b="0" i="0">
-                <a:solidFill>
-                  <a:srgbClr val="2B3642"/>
-                </a:solidFill>
-                <a:latin typeface="Calibri"/>
-              </a:rPr>
-              <a:t>▸  логистические меры ≠ WxHxD facing</a:t>
+              <a:rPr sz="1000" b="0" i="0">
+                <a:solidFill>
+                  <a:srgbClr val="FFFFFF"/>
+                </a:solidFill>
+                <a:latin typeface="Calibri"/>
+              </a:rPr>
+              <a:t>Ласмарт  ·  Товаровед  ·  карта конкурентов</a:t>
             </a:r>
           </a:p>
         </p:txBody>
@@ -5383,153 +5354,6 @@
       <p:sp>
         <p:nvSpPr>
           <p:cNvPr id="27" name="TextBox 26"/>
-          <p:cNvSpPr txBox="1"/>
-          <p:nvPr/>
-        </p:nvSpPr>
-        <p:spPr>
-          <a:xfrm>
-            <a:off x="6583680" y="5029200"/>
-            <a:ext cx="4754880" cy="365760"/>
-          </a:xfrm>
-          <a:prstGeom prst="rect">
-            <a:avLst/>
-          </a:prstGeom>
-          <a:noFill/>
-        </p:spPr>
-        <p:txBody>
-          <a:bodyPr wrap="square">
-            <a:spAutoFit/>
-          </a:bodyPr>
-          <a:lstStyle/>
-          <a:p>
-            <a:pPr algn="l"/>
-            <a:r>
-              <a:rPr sz="1000" b="0" i="0" u="sng">
-                <a:solidFill>
-                  <a:srgbClr val="4A6B7C"/>
-                </a:solidFill>
-                <a:latin typeface="Calibri"/>
-                <a:hlinkClick r:id="rId3"/>
-              </a:rPr>
-              <a:t>https://infostart.ru/marketplace/2667216/</a:t>
-            </a:r>
-          </a:p>
-        </p:txBody>
-      </p:sp>
-      <p:sp>
-        <p:nvSpPr>
-          <p:cNvPr id="28" name="TextBox 27"/>
-          <p:cNvSpPr txBox="1"/>
-          <p:nvPr/>
-        </p:nvSpPr>
-        <p:spPr>
-          <a:xfrm>
-            <a:off x="6583680" y="4754880"/>
-            <a:ext cx="4754880" cy="256032"/>
-          </a:xfrm>
-          <a:prstGeom prst="rect">
-            <a:avLst/>
-          </a:prstGeom>
-          <a:noFill/>
-        </p:spPr>
-        <p:txBody>
-          <a:bodyPr wrap="none">
-            <a:spAutoFit/>
-          </a:bodyPr>
-          <a:lstStyle/>
-          <a:p>
-            <a:r>
-              <a:rPr sz="1200" b="1" i="0">
-                <a:solidFill>
-                  <a:srgbClr val="3A5466"/>
-                </a:solidFill>
-                <a:latin typeface="Calibri"/>
-              </a:rPr>
-              <a:t>48 800 ₽ / мес + пакеты запросов</a:t>
-            </a:r>
-          </a:p>
-        </p:txBody>
-      </p:sp>
-      <p:sp>
-        <p:nvSpPr>
-          <p:cNvPr id="29" name="Rectangle 28"/>
-          <p:cNvSpPr/>
-          <p:nvPr/>
-        </p:nvSpPr>
-        <p:spPr>
-          <a:xfrm>
-            <a:off x="0" y="6656832"/>
-            <a:ext cx="12191695" cy="201168"/>
-          </a:xfrm>
-          <a:prstGeom prst="rect">
-            <a:avLst/>
-          </a:prstGeom>
-          <a:solidFill>
-            <a:srgbClr val="3A5466"/>
-          </a:solidFill>
-          <a:ln>
-            <a:noFill/>
-          </a:ln>
-        </p:spPr>
-        <p:style>
-          <a:lnRef idx="1">
-            <a:schemeClr val="accent1"/>
-          </a:lnRef>
-          <a:fillRef idx="3">
-            <a:schemeClr val="accent1"/>
-          </a:fillRef>
-          <a:effectRef idx="2">
-            <a:schemeClr val="accent1"/>
-          </a:effectRef>
-          <a:fontRef idx="minor">
-            <a:schemeClr val="lt1"/>
-          </a:fontRef>
-        </p:style>
-        <p:txBody>
-          <a:bodyPr rtlCol="0" anchor="ctr"/>
-          <a:lstStyle/>
-          <a:p>
-            <a:pPr algn="ctr"/>
-          </a:p>
-        </p:txBody>
-      </p:sp>
-      <p:sp>
-        <p:nvSpPr>
-          <p:cNvPr id="30" name="TextBox 29"/>
-          <p:cNvSpPr txBox="1"/>
-          <p:nvPr/>
-        </p:nvSpPr>
-        <p:spPr>
-          <a:xfrm>
-            <a:off x="457200" y="6656832"/>
-            <a:ext cx="9144000" cy="201168"/>
-          </a:xfrm>
-          <a:prstGeom prst="rect">
-            <a:avLst/>
-          </a:prstGeom>
-          <a:noFill/>
-        </p:spPr>
-        <p:txBody>
-          <a:bodyPr wrap="none">
-            <a:spAutoFit/>
-          </a:bodyPr>
-          <a:lstStyle/>
-          <a:p>
-            <a:r>
-              <a:rPr sz="1000" b="0" i="0">
-                <a:solidFill>
-                  <a:srgbClr val="FFFFFF"/>
-                </a:solidFill>
-                <a:latin typeface="Calibri"/>
-              </a:rPr>
-              <a:t>Ласмарт  ·  Товаровед  ·  карта конкурентов</a:t>
-            </a:r>
-          </a:p>
-        </p:txBody>
-      </p:sp>
-      <p:sp>
-        <p:nvSpPr>
-          <p:cNvPr id="31" name="TextBox 30"/>
           <p:cNvSpPr txBox="1"/>
           <p:nvPr/>
         </p:nvSpPr>

</xml_diff>